<commit_message>
Terminata presentazione, aggiunta immagine Sprint2
</commit_message>
<xml_diff>
--- a/Presentazione/Progetto_ISS25.pptx
+++ b/Presentazione/Progetto_ISS25.pptx
@@ -5,7 +5,7 @@
     <p:sldMasterId id="2147483660" r:id="rId1"/>
   </p:sldMasterIdLst>
   <p:notesMasterIdLst>
-    <p:notesMasterId r:id="rId9"/>
+    <p:notesMasterId r:id="rId10"/>
   </p:notesMasterIdLst>
   <p:sldIdLst>
     <p:sldId id="256" r:id="rId2"/>
@@ -13,8 +13,9 @@
     <p:sldId id="258" r:id="rId4"/>
     <p:sldId id="262" r:id="rId5"/>
     <p:sldId id="264" r:id="rId6"/>
-    <p:sldId id="265" r:id="rId7"/>
-    <p:sldId id="266" r:id="rId8"/>
+    <p:sldId id="267" r:id="rId7"/>
+    <p:sldId id="265" r:id="rId8"/>
+    <p:sldId id="266" r:id="rId9"/>
   </p:sldIdLst>
   <p:sldSz cx="12192000" cy="6858000"/>
   <p:notesSz cx="6858000" cy="9144000"/>
@@ -10683,8 +10684,8 @@
       </dsp:nvSpPr>
       <dsp:spPr>
         <a:xfrm>
-          <a:off x="35234" y="201679"/>
-          <a:ext cx="766779" cy="766779"/>
+          <a:off x="27061" y="123283"/>
+          <a:ext cx="819043" cy="819043"/>
         </a:xfrm>
         <a:prstGeom prst="ellipse">
           <a:avLst/>
@@ -10723,8 +10724,8 @@
       </dsp:nvSpPr>
       <dsp:spPr>
         <a:xfrm>
-          <a:off x="196258" y="362702"/>
-          <a:ext cx="444732" cy="444732"/>
+          <a:off x="199060" y="295283"/>
+          <a:ext cx="475045" cy="475045"/>
         </a:xfrm>
         <a:prstGeom prst="rect">
           <a:avLst/>
@@ -10780,8 +10781,8 @@
       </dsp:nvSpPr>
       <dsp:spPr>
         <a:xfrm>
-          <a:off x="966324" y="201679"/>
-          <a:ext cx="1807409" cy="766779"/>
+          <a:off x="1021614" y="123283"/>
+          <a:ext cx="1930602" cy="819043"/>
         </a:xfrm>
         <a:prstGeom prst="rect">
           <a:avLst/>
@@ -10810,7 +10811,7 @@
         </a:bodyPr>
         <a:lstStyle/>
         <a:p>
-          <a:pPr marL="0" lvl="0" indent="0" algn="l" defTabSz="577850">
+          <a:pPr marL="0" lvl="0" indent="0" algn="l" defTabSz="622300">
             <a:lnSpc>
               <a:spcPct val="100000"/>
             </a:lnSpc>
@@ -10823,19 +10824,19 @@
             <a:buNone/>
           </a:pPr>
           <a:r>
-            <a:rPr lang="it-IT" sz="1300" kern="1200" noProof="0" dirty="0"/>
+            <a:rPr lang="it-IT" sz="1400" kern="1200" noProof="0" dirty="0"/>
             <a:t>Formalizzazione dei </a:t>
           </a:r>
           <a:r>
-            <a:rPr lang="it-IT" sz="1300" b="1" kern="1200" noProof="0" dirty="0"/>
+            <a:rPr lang="it-IT" sz="1400" b="1" kern="1200" noProof="0" dirty="0"/>
             <a:t>requisiti del committente</a:t>
           </a:r>
-          <a:endParaRPr lang="it-IT" sz="1300" kern="1200" noProof="0" dirty="0"/>
+          <a:endParaRPr lang="it-IT" sz="1400" kern="1200" noProof="0" dirty="0"/>
         </a:p>
       </dsp:txBody>
       <dsp:txXfrm>
-        <a:off x="966324" y="201679"/>
-        <a:ext cx="1807409" cy="766779"/>
+        <a:off x="1021614" y="123283"/>
+        <a:ext cx="1930602" cy="819043"/>
       </dsp:txXfrm>
     </dsp:sp>
     <dsp:sp modelId="{DA2BD37A-79E2-422A-ADB0-220EDF61F2AF}">
@@ -10845,8 +10846,8 @@
       </dsp:nvSpPr>
       <dsp:spPr>
         <a:xfrm>
-          <a:off x="3088661" y="201679"/>
-          <a:ext cx="766779" cy="766779"/>
+          <a:off x="3288608" y="123283"/>
+          <a:ext cx="819043" cy="819043"/>
         </a:xfrm>
         <a:prstGeom prst="ellipse">
           <a:avLst/>
@@ -10885,8 +10886,8 @@
       </dsp:nvSpPr>
       <dsp:spPr>
         <a:xfrm>
-          <a:off x="3249685" y="362702"/>
-          <a:ext cx="444732" cy="444732"/>
+          <a:off x="3460607" y="295283"/>
+          <a:ext cx="475045" cy="475045"/>
         </a:xfrm>
         <a:prstGeom prst="rect">
           <a:avLst/>
@@ -10940,8 +10941,8 @@
       </dsp:nvSpPr>
       <dsp:spPr>
         <a:xfrm>
-          <a:off x="4019751" y="201679"/>
-          <a:ext cx="1807409" cy="766779"/>
+          <a:off x="4283161" y="123283"/>
+          <a:ext cx="1930602" cy="819043"/>
         </a:xfrm>
         <a:prstGeom prst="rect">
           <a:avLst/>
@@ -10970,7 +10971,7 @@
         </a:bodyPr>
         <a:lstStyle/>
         <a:p>
-          <a:pPr marL="0" lvl="0" indent="0" algn="l" defTabSz="577850">
+          <a:pPr marL="0" lvl="0" indent="0" algn="l" defTabSz="622300">
             <a:lnSpc>
               <a:spcPct val="100000"/>
             </a:lnSpc>
@@ -10983,27 +10984,27 @@
             <a:buNone/>
           </a:pPr>
           <a:r>
-            <a:rPr lang="it-IT" sz="1300" kern="1200" noProof="0" dirty="0"/>
+            <a:rPr lang="it-IT" sz="1400" kern="1200" noProof="0" dirty="0"/>
             <a:t>Analisi dei componenti </a:t>
           </a:r>
           <a:r>
-            <a:rPr lang="it-IT" sz="1300" b="1" kern="1200" noProof="0" dirty="0" err="1"/>
+            <a:rPr lang="it-IT" sz="1400" b="1" kern="1200" noProof="0" dirty="0" err="1"/>
             <a:t>basicrobot</a:t>
           </a:r>
           <a:r>
-            <a:rPr lang="it-IT" sz="1300" kern="1200" noProof="0" dirty="0"/>
+            <a:rPr lang="it-IT" sz="1400" kern="1200" noProof="0" dirty="0"/>
             <a:t> e </a:t>
           </a:r>
           <a:r>
-            <a:rPr lang="it-IT" sz="1300" b="1" kern="1200" noProof="0" dirty="0" err="1"/>
+            <a:rPr lang="it-IT" sz="1400" b="1" kern="1200" noProof="0" dirty="0" err="1"/>
             <a:t>productservice</a:t>
           </a:r>
-          <a:endParaRPr lang="it-IT" sz="1300" kern="1200" noProof="0" dirty="0"/>
+          <a:endParaRPr lang="it-IT" sz="1400" kern="1200" noProof="0" dirty="0"/>
         </a:p>
       </dsp:txBody>
       <dsp:txXfrm>
-        <a:off x="4019751" y="201679"/>
-        <a:ext cx="1807409" cy="766779"/>
+        <a:off x="4283161" y="123283"/>
+        <a:ext cx="1930602" cy="819043"/>
       </dsp:txXfrm>
     </dsp:sp>
     <dsp:sp modelId="{7F72141E-C048-46FB-931D-DEF369846BB7}">
@@ -11013,8 +11014,8 @@
       </dsp:nvSpPr>
       <dsp:spPr>
         <a:xfrm>
-          <a:off x="35234" y="1664866"/>
-          <a:ext cx="766779" cy="766779"/>
+          <a:off x="27061" y="1638734"/>
+          <a:ext cx="819043" cy="819043"/>
         </a:xfrm>
         <a:prstGeom prst="ellipse">
           <a:avLst/>
@@ -11053,8 +11054,8 @@
       </dsp:nvSpPr>
       <dsp:spPr>
         <a:xfrm>
-          <a:off x="196258" y="1825889"/>
-          <a:ext cx="444732" cy="444732"/>
+          <a:off x="199060" y="1810733"/>
+          <a:ext cx="475045" cy="475045"/>
         </a:xfrm>
         <a:prstGeom prst="rect">
           <a:avLst/>
@@ -11110,8 +11111,8 @@
       </dsp:nvSpPr>
       <dsp:spPr>
         <a:xfrm>
-          <a:off x="966324" y="1664866"/>
-          <a:ext cx="1807409" cy="766779"/>
+          <a:off x="1021614" y="1638734"/>
+          <a:ext cx="1930602" cy="819043"/>
         </a:xfrm>
         <a:prstGeom prst="rect">
           <a:avLst/>
@@ -11140,7 +11141,7 @@
         </a:bodyPr>
         <a:lstStyle/>
         <a:p>
-          <a:pPr marL="0" lvl="0" indent="0" algn="l" defTabSz="577850">
+          <a:pPr marL="0" lvl="0" indent="0" algn="l" defTabSz="622300">
             <a:lnSpc>
               <a:spcPct val="100000"/>
             </a:lnSpc>
@@ -11153,19 +11154,19 @@
             <a:buNone/>
           </a:pPr>
           <a:r>
-            <a:rPr lang="it-IT" sz="1300" kern="1200" noProof="0" dirty="0"/>
+            <a:rPr lang="it-IT" sz="1400" kern="1200" noProof="0" dirty="0"/>
             <a:t>Mappatura della </a:t>
           </a:r>
           <a:r>
-            <a:rPr lang="it-IT" sz="1300" b="1" kern="1200" noProof="0" dirty="0" err="1"/>
+            <a:rPr lang="it-IT" sz="1400" b="1" kern="1200" noProof="0" dirty="0" err="1"/>
             <a:t>Hold</a:t>
           </a:r>
-          <a:endParaRPr lang="it-IT" sz="1300" kern="1200" noProof="0" dirty="0"/>
+          <a:endParaRPr lang="it-IT" sz="1400" kern="1200" noProof="0" dirty="0"/>
         </a:p>
       </dsp:txBody>
       <dsp:txXfrm>
-        <a:off x="966324" y="1664866"/>
-        <a:ext cx="1807409" cy="766779"/>
+        <a:off x="1021614" y="1638734"/>
+        <a:ext cx="1930602" cy="819043"/>
       </dsp:txXfrm>
     </dsp:sp>
     <dsp:sp modelId="{9CF86B7E-23B2-463C-9FB5-7EB22012CD83}">
@@ -11175,8 +11176,8 @@
       </dsp:nvSpPr>
       <dsp:spPr>
         <a:xfrm>
-          <a:off x="3088661" y="1664866"/>
-          <a:ext cx="766779" cy="766779"/>
+          <a:off x="3288608" y="1638734"/>
+          <a:ext cx="819043" cy="819043"/>
         </a:xfrm>
         <a:prstGeom prst="ellipse">
           <a:avLst/>
@@ -11215,8 +11216,8 @@
       </dsp:nvSpPr>
       <dsp:spPr>
         <a:xfrm>
-          <a:off x="3249685" y="1825889"/>
-          <a:ext cx="444732" cy="444732"/>
+          <a:off x="3460607" y="1810733"/>
+          <a:ext cx="475045" cy="475045"/>
         </a:xfrm>
         <a:prstGeom prst="rect">
           <a:avLst/>
@@ -11272,8 +11273,8 @@
       </dsp:nvSpPr>
       <dsp:spPr>
         <a:xfrm>
-          <a:off x="4019751" y="1664866"/>
-          <a:ext cx="1807409" cy="766779"/>
+          <a:off x="4283161" y="1638734"/>
+          <a:ext cx="1930602" cy="819043"/>
         </a:xfrm>
         <a:prstGeom prst="rect">
           <a:avLst/>
@@ -11302,7 +11303,7 @@
         </a:bodyPr>
         <a:lstStyle/>
         <a:p>
-          <a:pPr marL="0" lvl="0" indent="0" algn="l" defTabSz="577850">
+          <a:pPr marL="0" lvl="0" indent="0" algn="l" defTabSz="622300">
             <a:lnSpc>
               <a:spcPct val="100000"/>
             </a:lnSpc>
@@ -11315,19 +11316,19 @@
             <a:buNone/>
           </a:pPr>
           <a:r>
-            <a:rPr lang="it-IT" sz="1300" kern="1200" noProof="0" dirty="0"/>
+            <a:rPr lang="it-IT" sz="1400" kern="1200" noProof="0" dirty="0"/>
             <a:t>Definizione dell’</a:t>
           </a:r>
           <a:r>
-            <a:rPr lang="it-IT" sz="1300" b="1" kern="1200" noProof="0" dirty="0"/>
+            <a:rPr lang="it-IT" sz="1400" b="1" kern="1200" noProof="0" dirty="0"/>
             <a:t>architettura logica del sistema</a:t>
           </a:r>
-          <a:endParaRPr lang="it-IT" sz="1300" kern="1200" noProof="0" dirty="0"/>
+          <a:endParaRPr lang="it-IT" sz="1400" kern="1200" noProof="0" dirty="0"/>
         </a:p>
       </dsp:txBody>
       <dsp:txXfrm>
-        <a:off x="4019751" y="1664866"/>
-        <a:ext cx="1807409" cy="766779"/>
+        <a:off x="4283161" y="1638734"/>
+        <a:ext cx="1930602" cy="819043"/>
       </dsp:txXfrm>
     </dsp:sp>
     <dsp:sp modelId="{EC64706F-0005-400B-AF55-5E1DC44F8EFB}">
@@ -11337,8 +11338,8 @@
       </dsp:nvSpPr>
       <dsp:spPr>
         <a:xfrm>
-          <a:off x="35234" y="3128052"/>
-          <a:ext cx="766779" cy="766779"/>
+          <a:off x="27061" y="3154184"/>
+          <a:ext cx="819043" cy="819043"/>
         </a:xfrm>
         <a:prstGeom prst="ellipse">
           <a:avLst/>
@@ -11377,8 +11378,8 @@
       </dsp:nvSpPr>
       <dsp:spPr>
         <a:xfrm>
-          <a:off x="196258" y="3289076"/>
-          <a:ext cx="444732" cy="444732"/>
+          <a:off x="199060" y="3326183"/>
+          <a:ext cx="475045" cy="475045"/>
         </a:xfrm>
         <a:prstGeom prst="rect">
           <a:avLst/>
@@ -11432,8 +11433,8 @@
       </dsp:nvSpPr>
       <dsp:spPr>
         <a:xfrm>
-          <a:off x="966324" y="3128052"/>
-          <a:ext cx="1807409" cy="766779"/>
+          <a:off x="1021614" y="3154184"/>
+          <a:ext cx="1930602" cy="819043"/>
         </a:xfrm>
         <a:prstGeom prst="rect">
           <a:avLst/>
@@ -11462,7 +11463,7 @@
         </a:bodyPr>
         <a:lstStyle/>
         <a:p>
-          <a:pPr marL="0" lvl="0" indent="0" algn="l" defTabSz="577850">
+          <a:pPr marL="0" lvl="0" indent="0" algn="l" defTabSz="622300">
             <a:lnSpc>
               <a:spcPct val="100000"/>
             </a:lnSpc>
@@ -11475,22 +11476,22 @@
             <a:buNone/>
           </a:pPr>
           <a:r>
-            <a:rPr lang="it-IT" sz="1300" kern="1200" noProof="0" dirty="0"/>
+            <a:rPr lang="it-IT" sz="1400" kern="1200" noProof="0" dirty="0"/>
             <a:t>Definizione di un </a:t>
           </a:r>
           <a:r>
-            <a:rPr lang="it-IT" sz="1300" b="1" kern="1200" noProof="0" dirty="0"/>
+            <a:rPr lang="it-IT" sz="1400" b="1" kern="1200" noProof="0" dirty="0"/>
             <a:t>piano di testing </a:t>
           </a:r>
           <a:r>
-            <a:rPr lang="it-IT" sz="1300" kern="1200" noProof="0" dirty="0"/>
+            <a:rPr lang="it-IT" sz="1400" kern="1200" noProof="0" dirty="0"/>
             <a:t>iniziale</a:t>
           </a:r>
         </a:p>
       </dsp:txBody>
       <dsp:txXfrm>
-        <a:off x="966324" y="3128052"/>
-        <a:ext cx="1807409" cy="766779"/>
+        <a:off x="1021614" y="3154184"/>
+        <a:ext cx="1930602" cy="819043"/>
       </dsp:txXfrm>
     </dsp:sp>
   </dsp:spTree>
@@ -25811,7 +25812,7 @@
           <a:p>
             <a:fld id="{13979451-7F4F-48F7-9661-2B1C2EB7BD6E}" type="datetimeFigureOut">
               <a:rPr lang="it-IT" smtClean="0"/>
-              <a:t>22/11/2025</a:t>
+              <a:t>28/11/2025</a:t>
             </a:fld>
             <a:endParaRPr lang="it-IT"/>
           </a:p>
@@ -26551,7 +26552,7 @@
           <a:p>
             <a:fld id="{AFFC8205-DE80-478C-AD6F-2A649EE9AA9A}" type="slidenum">
               <a:rPr lang="it-IT" smtClean="0"/>
-              <a:t>6</a:t>
+              <a:t>7</a:t>
             </a:fld>
             <a:endParaRPr lang="it-IT"/>
           </a:p>
@@ -26723,7 +26724,7 @@
           <a:p>
             <a:fld id="{C128FA71-3A18-48C0-980F-4B68F7F63042}" type="datetime1">
               <a:rPr lang="en-US" smtClean="0"/>
-              <a:t>11/22/2025</a:t>
+              <a:t>11/28/2025</a:t>
             </a:fld>
             <a:endParaRPr lang="en-US"/>
           </a:p>
@@ -26931,7 +26932,7 @@
           <a:p>
             <a:fld id="{7104EDB3-C0E8-45F8-9E1D-1B6C8D1880C0}" type="datetime1">
               <a:rPr lang="en-US" smtClean="0"/>
-              <a:t>11/22/2025</a:t>
+              <a:t>11/28/2025</a:t>
             </a:fld>
             <a:endParaRPr lang="en-US"/>
           </a:p>
@@ -27141,7 +27142,7 @@
           <a:p>
             <a:fld id="{9CF0EC4B-54ED-4041-B552-9BA760FA3DBA}" type="datetime1">
               <a:rPr lang="en-US" smtClean="0"/>
-              <a:t>11/22/2025</a:t>
+              <a:t>11/28/2025</a:t>
             </a:fld>
             <a:endParaRPr lang="en-US"/>
           </a:p>
@@ -27339,7 +27340,7 @@
           <a:p>
             <a:fld id="{51C1210E-201E-4473-82AC-2466F5386C38}" type="datetime1">
               <a:rPr lang="en-US" smtClean="0"/>
-              <a:t>11/22/2025</a:t>
+              <a:t>11/28/2025</a:t>
             </a:fld>
             <a:endParaRPr lang="en-US"/>
           </a:p>
@@ -27617,7 +27618,7 @@
           <a:p>
             <a:fld id="{B01EA198-6CAB-4B8F-B93F-1F9C8C4B6CE7}" type="datetime1">
               <a:rPr lang="en-US" smtClean="0"/>
-              <a:t>11/22/2025</a:t>
+              <a:t>11/28/2025</a:t>
             </a:fld>
             <a:endParaRPr lang="en-US"/>
           </a:p>
@@ -27889,7 +27890,7 @@
           <a:p>
             <a:fld id="{CA06041F-4525-44D5-AA4F-332294BF1F56}" type="datetime1">
               <a:rPr lang="en-US" smtClean="0"/>
-              <a:t>11/22/2025</a:t>
+              <a:t>11/28/2025</a:t>
             </a:fld>
             <a:endParaRPr lang="en-US"/>
           </a:p>
@@ -28313,7 +28314,7 @@
           <a:p>
             <a:fld id="{F9557091-BBDF-4EB9-BA6B-2BB67AC4FC0F}" type="datetime1">
               <a:rPr lang="en-US" smtClean="0"/>
-              <a:t>11/22/2025</a:t>
+              <a:t>11/28/2025</a:t>
             </a:fld>
             <a:endParaRPr lang="en-US"/>
           </a:p>
@@ -28454,7 +28455,7 @@
           <a:p>
             <a:fld id="{2D6B226B-77A6-410C-9796-083F278E0125}" type="datetime1">
               <a:rPr lang="en-US" smtClean="0"/>
-              <a:t>11/22/2025</a:t>
+              <a:t>11/28/2025</a:t>
             </a:fld>
             <a:endParaRPr lang="en-US"/>
           </a:p>
@@ -28567,7 +28568,7 @@
           <a:p>
             <a:fld id="{A23A578B-D289-4C40-8593-3D356C49DA58}" type="datetime1">
               <a:rPr lang="en-US" smtClean="0"/>
-              <a:t>11/22/2025</a:t>
+              <a:t>11/28/2025</a:t>
             </a:fld>
             <a:endParaRPr lang="en-US"/>
           </a:p>
@@ -28886,7 +28887,7 @@
           <a:p>
             <a:fld id="{713DFAE3-14DB-48A7-A80F-80DDB072CE3D}" type="datetime1">
               <a:rPr lang="en-US" smtClean="0"/>
-              <a:t>11/22/2025</a:t>
+              <a:t>11/28/2025</a:t>
             </a:fld>
             <a:endParaRPr lang="en-US"/>
           </a:p>
@@ -29180,7 +29181,7 @@
           <a:p>
             <a:fld id="{92C5EAEF-6478-4102-8F5D-A5FE9FC97ACB}" type="datetime1">
               <a:rPr lang="en-US" smtClean="0"/>
-              <a:t>11/22/2025</a:t>
+              <a:t>11/28/2025</a:t>
             </a:fld>
             <a:endParaRPr lang="en-US"/>
           </a:p>
@@ -29421,7 +29422,7 @@
           <a:p>
             <a:fld id="{67F45AC6-C491-4585-A584-9CE2AF7D5500}" type="datetime1">
               <a:rPr lang="en-US" smtClean="0"/>
-              <a:t>11/22/2025</a:t>
+              <a:t>11/28/2025</a:t>
             </a:fld>
             <a:endParaRPr lang="en-US"/>
           </a:p>
@@ -30222,14 +30223,14 @@
             <p:ph idx="1"/>
             <p:extLst>
               <p:ext uri="{D42A27DB-BD31-4B8C-83A1-F6EECF244321}">
-                <p14:modId xmlns:p14="http://schemas.microsoft.com/office/powerpoint/2010/main" val="1847157669"/>
+                <p14:modId xmlns:p14="http://schemas.microsoft.com/office/powerpoint/2010/main" val="3010661227"/>
               </p:ext>
             </p:extLst>
           </p:nvPr>
         </p:nvGraphicFramePr>
         <p:xfrm>
-          <a:off x="612648" y="2356490"/>
-          <a:ext cx="5862396" cy="4096512"/>
+          <a:off x="612647" y="2356490"/>
+          <a:ext cx="6240825" cy="4096512"/>
         </p:xfrm>
         <a:graphic>
           <a:graphicData uri="http://schemas.openxmlformats.org/drawingml/2006/diagram">
@@ -30253,19 +30254,32 @@
         </p:nvPicPr>
         <p:blipFill>
           <a:blip r:embed="rId7"/>
-          <a:srcRect l="13410" t="10185" r="13152" b="12315"/>
+          <a:srcRect l="13410" t="10185" r="13439" b="12315"/>
           <a:stretch>
             <a:fillRect/>
           </a:stretch>
         </p:blipFill>
         <p:spPr>
           <a:xfrm>
-            <a:off x="7392928" y="433384"/>
-            <a:ext cx="4078439" cy="6019618"/>
+            <a:off x="7392929" y="433384"/>
+            <a:ext cx="4062472" cy="6019618"/>
           </a:xfrm>
           <a:prstGeom prst="rect">
             <a:avLst/>
           </a:prstGeom>
+          <a:ln w="28575" cap="sq">
+            <a:solidFill>
+              <a:srgbClr val="000000"/>
+            </a:solidFill>
+            <a:miter lim="800000"/>
+          </a:ln>
+          <a:effectLst>
+            <a:outerShdw blurRad="57150" dist="50800" dir="2700000" algn="tl" rotWithShape="0">
+              <a:srgbClr val="000000">
+                <a:alpha val="40000"/>
+              </a:srgbClr>
+            </a:outerShdw>
+          </a:effectLst>
         </p:spPr>
       </p:pic>
     </p:spTree>
@@ -30880,6 +30894,159 @@
   <p:cSld>
     <p:spTree>
       <p:nvGrpSpPr>
+        <p:cNvPr id="1" name=""/>
+        <p:cNvGrpSpPr/>
+        <p:nvPr/>
+      </p:nvGrpSpPr>
+      <p:grpSpPr>
+        <a:xfrm>
+          <a:off x="0" y="0"/>
+          <a:ext cx="0" cy="0"/>
+          <a:chOff x="0" y="0"/>
+          <a:chExt cx="0" cy="0"/>
+        </a:xfrm>
+      </p:grpSpPr>
+      <p:sp>
+        <p:nvSpPr>
+          <p:cNvPr id="7" name="Titolo 6">
+            <a:extLst>
+              <a:ext uri="{FF2B5EF4-FFF2-40B4-BE49-F238E27FC236}">
+                <a16:creationId xmlns:a16="http://schemas.microsoft.com/office/drawing/2014/main" id="{B29866C5-D425-E4B5-167A-9BE25644B2C2}"/>
+              </a:ext>
+            </a:extLst>
+          </p:cNvPr>
+          <p:cNvSpPr>
+            <a:spLocks noGrp="1"/>
+          </p:cNvSpPr>
+          <p:nvPr>
+            <p:ph type="title"/>
+          </p:nvPr>
+        </p:nvSpPr>
+        <p:spPr/>
+        <p:txBody>
+          <a:bodyPr/>
+          <a:lstStyle/>
+          <a:p>
+            <a:r>
+              <a:rPr lang="it-IT" sz="3300" dirty="0"/>
+              <a:t>Sprint</a:t>
+            </a:r>
+            <a:r>
+              <a:rPr lang="it-IT" dirty="0"/>
+              <a:t> 2 – Movimento del Robot e I/O devices </a:t>
+            </a:r>
+          </a:p>
+        </p:txBody>
+      </p:sp>
+      <p:pic>
+        <p:nvPicPr>
+          <p:cNvPr id="14" name="Segnaposto contenuto 13" descr="Immagine che contiene testo, diagramma, schermata, linea&#10;&#10;Il contenuto generato dall'IA potrebbe non essere corretto.">
+            <a:extLst>
+              <a:ext uri="{FF2B5EF4-FFF2-40B4-BE49-F238E27FC236}">
+                <a16:creationId xmlns:a16="http://schemas.microsoft.com/office/drawing/2014/main" id="{B91BC5A3-0167-6ADA-12A8-93451C6A7709}"/>
+              </a:ext>
+            </a:extLst>
+          </p:cNvPr>
+          <p:cNvPicPr>
+            <a:picLocks noGrp="1" noChangeAspect="1"/>
+          </p:cNvPicPr>
+          <p:nvPr>
+            <p:ph idx="1"/>
+          </p:nvPr>
+        </p:nvPicPr>
+        <p:blipFill>
+          <a:blip r:embed="rId2">
+            <a:extLst>
+              <a:ext uri="{28A0092B-C50C-407E-A947-70E740481C1C}">
+                <a14:useLocalDpi xmlns:a14="http://schemas.microsoft.com/office/drawing/2010/main" val="0"/>
+              </a:ext>
+            </a:extLst>
+          </a:blip>
+          <a:srcRect l="5891" t="11856" r="5641" b="14587"/>
+          <a:stretch>
+            <a:fillRect/>
+          </a:stretch>
+        </p:blipFill>
+        <p:spPr>
+          <a:xfrm>
+            <a:off x="250825" y="2333625"/>
+            <a:ext cx="10264775" cy="4238625"/>
+          </a:xfrm>
+          <a:ln w="28575">
+            <a:solidFill>
+              <a:schemeClr val="tx1"/>
+            </a:solidFill>
+          </a:ln>
+        </p:spPr>
+      </p:pic>
+      <p:pic>
+        <p:nvPicPr>
+          <p:cNvPr id="16" name="Immagine 15" descr="Immagine che contiene testo, schermata, diagramma, Carattere&#10;&#10;Il contenuto generato dall'IA potrebbe non essere corretto.">
+            <a:extLst>
+              <a:ext uri="{FF2B5EF4-FFF2-40B4-BE49-F238E27FC236}">
+                <a16:creationId xmlns:a16="http://schemas.microsoft.com/office/drawing/2014/main" id="{33A831B8-11AF-F62B-03C8-F2A6667CAE6D}"/>
+              </a:ext>
+            </a:extLst>
+          </p:cNvPr>
+          <p:cNvPicPr>
+            <a:picLocks noChangeAspect="1"/>
+          </p:cNvPicPr>
+          <p:nvPr/>
+        </p:nvPicPr>
+        <p:blipFill>
+          <a:blip r:embed="rId3">
+            <a:extLst>
+              <a:ext uri="{28A0092B-C50C-407E-A947-70E740481C1C}">
+                <a14:useLocalDpi xmlns:a14="http://schemas.microsoft.com/office/drawing/2010/main" val="0"/>
+              </a:ext>
+            </a:extLst>
+          </a:blip>
+          <a:srcRect l="14974" t="20416" r="14263" b="25139"/>
+          <a:stretch>
+            <a:fillRect/>
+          </a:stretch>
+        </p:blipFill>
+        <p:spPr>
+          <a:xfrm>
+            <a:off x="6071677" y="1436430"/>
+            <a:ext cx="5863147" cy="3297495"/>
+          </a:xfrm>
+          <a:prstGeom prst="rect">
+            <a:avLst/>
+          </a:prstGeom>
+          <a:ln w="28575" cap="sq">
+            <a:solidFill>
+              <a:srgbClr val="000000"/>
+            </a:solidFill>
+            <a:miter lim="800000"/>
+          </a:ln>
+          <a:effectLst>
+            <a:outerShdw blurRad="57150" dist="50800" dir="2700000" algn="tl" rotWithShape="0">
+              <a:srgbClr val="000000">
+                <a:alpha val="40000"/>
+              </a:srgbClr>
+            </a:outerShdw>
+          </a:effectLst>
+        </p:spPr>
+      </p:pic>
+    </p:spTree>
+    <p:extLst>
+      <p:ext uri="{BB962C8B-B14F-4D97-AF65-F5344CB8AC3E}">
+        <p14:creationId xmlns:p14="http://schemas.microsoft.com/office/powerpoint/2010/main" val="461314991"/>
+      </p:ext>
+    </p:extLst>
+  </p:cSld>
+  <p:clrMapOvr>
+    <a:masterClrMapping/>
+  </p:clrMapOvr>
+</p:sld>
+</file>
+
+<file path=ppt/slides/slide7.xml><?xml version="1.0" encoding="utf-8"?>
+<p:sld xmlns:a="http://schemas.openxmlformats.org/drawingml/2006/main" xmlns:r="http://schemas.openxmlformats.org/officeDocument/2006/relationships" xmlns:p="http://schemas.openxmlformats.org/presentationml/2006/main">
+  <p:cSld>
+    <p:spTree>
+      <p:nvGrpSpPr>
         <p:cNvPr id="1" name="">
           <a:extLst>
             <a:ext uri="{FF2B5EF4-FFF2-40B4-BE49-F238E27FC236}">
@@ -31083,7 +31250,7 @@
 </p:sld>
 </file>
 
-<file path=ppt/slides/slide7.xml><?xml version="1.0" encoding="utf-8"?>
+<file path=ppt/slides/slide8.xml><?xml version="1.0" encoding="utf-8"?>
 <p:sld xmlns:a="http://schemas.openxmlformats.org/drawingml/2006/main" xmlns:r="http://schemas.openxmlformats.org/officeDocument/2006/relationships" xmlns:p="http://schemas.openxmlformats.org/presentationml/2006/main">
   <p:cSld>
     <p:spTree>

</xml_diff>